<commit_message>
Adiciona PDF da apresentacao final
</commit_message>
<xml_diff>
--- a/doc/Plataforma de Telemedicina - Apresentação Final.pptx
+++ b/doc/Plataforma de Telemedicina - Apresentação Final.pptx
@@ -5,21 +5,22 @@
     <p:sldMasterId id="2147483684" r:id="rId4"/>
   </p:sldMasterIdLst>
   <p:notesMasterIdLst>
-    <p:notesMasterId r:id="rId14"/>
+    <p:notesMasterId r:id="rId15"/>
   </p:notesMasterIdLst>
   <p:handoutMasterIdLst>
-    <p:handoutMasterId r:id="rId15"/>
+    <p:handoutMasterId r:id="rId16"/>
   </p:handoutMasterIdLst>
   <p:sldIdLst>
     <p:sldId id="278" r:id="rId5"/>
     <p:sldId id="282" r:id="rId6"/>
     <p:sldId id="293" r:id="rId7"/>
     <p:sldId id="283" r:id="rId8"/>
-    <p:sldId id="284" r:id="rId9"/>
-    <p:sldId id="286" r:id="rId10"/>
-    <p:sldId id="287" r:id="rId11"/>
-    <p:sldId id="288" r:id="rId12"/>
-    <p:sldId id="292" r:id="rId13"/>
+    <p:sldId id="294" r:id="rId9"/>
+    <p:sldId id="284" r:id="rId10"/>
+    <p:sldId id="286" r:id="rId11"/>
+    <p:sldId id="287" r:id="rId12"/>
+    <p:sldId id="288" r:id="rId13"/>
+    <p:sldId id="292" r:id="rId14"/>
   </p:sldIdLst>
   <p:sldSz cx="12192000" cy="6858000"/>
   <p:notesSz cx="6858000" cy="9144000"/>
@@ -789,6 +790,100 @@
 </p:notes>
 </file>
 
+<file path=ppt/notesSlides/notesSlide10.xml><?xml version="1.0" encoding="utf-8"?>
+<p:notes xmlns:a="http://schemas.openxmlformats.org/drawingml/2006/main" xmlns:r="http://schemas.openxmlformats.org/officeDocument/2006/relationships" xmlns:p="http://schemas.openxmlformats.org/presentationml/2006/main">
+  <p:cSld>
+    <p:spTree>
+      <p:nvGrpSpPr>
+        <p:cNvPr id="1" name=""/>
+        <p:cNvGrpSpPr/>
+        <p:nvPr/>
+      </p:nvGrpSpPr>
+      <p:grpSpPr>
+        <a:xfrm>
+          <a:off x="0" y="0"/>
+          <a:ext cx="0" cy="0"/>
+          <a:chOff x="0" y="0"/>
+          <a:chExt cx="0" cy="0"/>
+        </a:xfrm>
+      </p:grpSpPr>
+      <p:sp>
+        <p:nvSpPr>
+          <p:cNvPr id="2" name="Espaço Reservado para Imagem do Slide 1"/>
+          <p:cNvSpPr>
+            <a:spLocks noGrp="1" noRot="1" noChangeAspect="1"/>
+          </p:cNvSpPr>
+          <p:nvPr>
+            <p:ph type="sldImg"/>
+          </p:nvPr>
+        </p:nvSpPr>
+        <p:spPr/>
+      </p:sp>
+      <p:sp>
+        <p:nvSpPr>
+          <p:cNvPr id="3" name="Espaço Reservado para Notas 2"/>
+          <p:cNvSpPr>
+            <a:spLocks noGrp="1"/>
+          </p:cNvSpPr>
+          <p:nvPr>
+            <p:ph type="body" idx="1"/>
+          </p:nvPr>
+        </p:nvSpPr>
+        <p:spPr/>
+        <p:txBody>
+          <a:bodyPr rtlCol="0"/>
+          <a:lstStyle>
+            <a:defPPr>
+              <a:defRPr lang="pt-BR"/>
+            </a:defPPr>
+          </a:lstStyle>
+          <a:p>
+            <a:pPr rtl="0"/>
+            <a:endParaRPr lang="pt-BR" dirty="0"/>
+          </a:p>
+        </p:txBody>
+      </p:sp>
+      <p:sp>
+        <p:nvSpPr>
+          <p:cNvPr id="4" name="Espaço Reservado para o Número do Slide 3"/>
+          <p:cNvSpPr>
+            <a:spLocks noGrp="1"/>
+          </p:cNvSpPr>
+          <p:nvPr>
+            <p:ph type="sldNum" sz="quarter" idx="5"/>
+          </p:nvPr>
+        </p:nvSpPr>
+        <p:spPr/>
+        <p:txBody>
+          <a:bodyPr rtlCol="0"/>
+          <a:lstStyle>
+            <a:defPPr>
+              <a:defRPr lang="pt-BR"/>
+            </a:defPPr>
+          </a:lstStyle>
+          <a:p>
+            <a:pPr rtl="0"/>
+            <a:fld id="{E7AF00E9-A49D-4007-B3B9-A3783809E505}" type="slidenum">
+              <a:rPr lang="pt-BR" smtClean="0"/>
+              <a:t>10</a:t>
+            </a:fld>
+            <a:endParaRPr lang="pt-BR" dirty="0"/>
+          </a:p>
+        </p:txBody>
+      </p:sp>
+    </p:spTree>
+    <p:extLst>
+      <p:ext uri="{BB962C8B-B14F-4D97-AF65-F5344CB8AC3E}">
+        <p14:creationId xmlns:p14="http://schemas.microsoft.com/office/powerpoint/2010/main" val="1049693401"/>
+      </p:ext>
+    </p:extLst>
+  </p:cSld>
+  <p:clrMapOvr>
+    <a:masterClrMapping/>
+  </p:clrMapOvr>
+</p:notes>
+</file>
+
 <file path=ppt/notesSlides/notesSlide2.xml><?xml version="1.0" encoding="utf-8"?>
 <p:notes xmlns:a="http://schemas.openxmlformats.org/drawingml/2006/main" xmlns:r="http://schemas.openxmlformats.org/officeDocument/2006/relationships" xmlns:p="http://schemas.openxmlformats.org/presentationml/2006/main">
   <p:cSld>
@@ -1155,7 +1250,7 @@
     </p:spTree>
     <p:extLst>
       <p:ext uri="{BB962C8B-B14F-4D97-AF65-F5344CB8AC3E}">
-        <p14:creationId xmlns:p14="http://schemas.microsoft.com/office/powerpoint/2010/main" val="386789978"/>
+        <p14:creationId xmlns:p14="http://schemas.microsoft.com/office/powerpoint/2010/main" val="1128711883"/>
       </p:ext>
     </p:extLst>
   </p:cSld>
@@ -1249,7 +1344,7 @@
     </p:spTree>
     <p:extLst>
       <p:ext uri="{BB962C8B-B14F-4D97-AF65-F5344CB8AC3E}">
-        <p14:creationId xmlns:p14="http://schemas.microsoft.com/office/powerpoint/2010/main" val="3070488982"/>
+        <p14:creationId xmlns:p14="http://schemas.microsoft.com/office/powerpoint/2010/main" val="386789978"/>
       </p:ext>
     </p:extLst>
   </p:cSld>
@@ -1343,7 +1438,7 @@
     </p:spTree>
     <p:extLst>
       <p:ext uri="{BB962C8B-B14F-4D97-AF65-F5344CB8AC3E}">
-        <p14:creationId xmlns:p14="http://schemas.microsoft.com/office/powerpoint/2010/main" val="2661674522"/>
+        <p14:creationId xmlns:p14="http://schemas.microsoft.com/office/powerpoint/2010/main" val="3070488982"/>
       </p:ext>
     </p:extLst>
   </p:cSld>
@@ -1437,7 +1532,7 @@
     </p:spTree>
     <p:extLst>
       <p:ext uri="{BB962C8B-B14F-4D97-AF65-F5344CB8AC3E}">
-        <p14:creationId xmlns:p14="http://schemas.microsoft.com/office/powerpoint/2010/main" val="382281238"/>
+        <p14:creationId xmlns:p14="http://schemas.microsoft.com/office/powerpoint/2010/main" val="2661674522"/>
       </p:ext>
     </p:extLst>
   </p:cSld>
@@ -1531,7 +1626,7 @@
     </p:spTree>
     <p:extLst>
       <p:ext uri="{BB962C8B-B14F-4D97-AF65-F5344CB8AC3E}">
-        <p14:creationId xmlns:p14="http://schemas.microsoft.com/office/powerpoint/2010/main" val="1049693401"/>
+        <p14:creationId xmlns:p14="http://schemas.microsoft.com/office/powerpoint/2010/main" val="382281238"/>
       </p:ext>
     </p:extLst>
   </p:cSld>
@@ -12372,6 +12467,180 @@
 </p:sld>
 </file>
 
+<file path=ppt/slides/slide10.xml><?xml version="1.0" encoding="utf-8"?>
+<p:sld xmlns:a="http://schemas.openxmlformats.org/drawingml/2006/main" xmlns:r="http://schemas.openxmlformats.org/officeDocument/2006/relationships" xmlns:p="http://schemas.openxmlformats.org/presentationml/2006/main">
+  <p:cSld>
+    <p:spTree>
+      <p:nvGrpSpPr>
+        <p:cNvPr id="1" name=""/>
+        <p:cNvGrpSpPr/>
+        <p:nvPr/>
+      </p:nvGrpSpPr>
+      <p:grpSpPr>
+        <a:xfrm>
+          <a:off x="0" y="0"/>
+          <a:ext cx="0" cy="0"/>
+          <a:chOff x="0" y="0"/>
+          <a:chExt cx="0" cy="0"/>
+        </a:xfrm>
+      </p:grpSpPr>
+      <p:sp>
+        <p:nvSpPr>
+          <p:cNvPr id="2" name="Título 1">
+            <a:extLst>
+              <a:ext uri="{FF2B5EF4-FFF2-40B4-BE49-F238E27FC236}">
+                <a16:creationId xmlns:a16="http://schemas.microsoft.com/office/drawing/2014/main" id="{28BAC361-0D7A-DC05-86B5-6DD77D322F5B}"/>
+              </a:ext>
+            </a:extLst>
+          </p:cNvPr>
+          <p:cNvSpPr>
+            <a:spLocks noGrp="1"/>
+          </p:cNvSpPr>
+          <p:nvPr>
+            <p:ph type="title"/>
+          </p:nvPr>
+        </p:nvSpPr>
+        <p:spPr>
+          <a:xfrm>
+            <a:off x="549536" y="549275"/>
+            <a:ext cx="5179330" cy="1082302"/>
+          </a:xfrm>
+          <a:noFill/>
+        </p:spPr>
+        <p:txBody>
+          <a:bodyPr rtlCol="0" anchor="b">
+            <a:normAutofit/>
+          </a:bodyPr>
+          <a:lstStyle>
+            <a:defPPr>
+              <a:defRPr lang="pt-BR"/>
+            </a:defPPr>
+          </a:lstStyle>
+          <a:p>
+            <a:pPr rtl="0"/>
+            <a:r>
+              <a:rPr lang="pt-BR" dirty="0"/>
+              <a:t>Obrigado!</a:t>
+            </a:r>
+          </a:p>
+        </p:txBody>
+      </p:sp>
+      <p:sp>
+        <p:nvSpPr>
+          <p:cNvPr id="3" name="Espaço Reservado para Conteúdo 2">
+            <a:extLst>
+              <a:ext uri="{FF2B5EF4-FFF2-40B4-BE49-F238E27FC236}">
+                <a16:creationId xmlns:a16="http://schemas.microsoft.com/office/drawing/2014/main" id="{1BE98EFF-197D-3136-70B9-7BBD30A48931}"/>
+              </a:ext>
+            </a:extLst>
+          </p:cNvPr>
+          <p:cNvSpPr>
+            <a:spLocks noGrp="1"/>
+          </p:cNvSpPr>
+          <p:nvPr>
+            <p:ph idx="1"/>
+          </p:nvPr>
+        </p:nvSpPr>
+        <p:spPr>
+          <a:xfrm>
+            <a:off x="549536" y="2090207"/>
+            <a:ext cx="5179330" cy="2706160"/>
+          </a:xfrm>
+          <a:noFill/>
+        </p:spPr>
+        <p:txBody>
+          <a:bodyPr rtlCol="0">
+            <a:normAutofit/>
+          </a:bodyPr>
+          <a:lstStyle>
+            <a:defPPr>
+              <a:defRPr lang="pt-BR"/>
+            </a:defPPr>
+          </a:lstStyle>
+          <a:p>
+            <a:pPr rtl="0"/>
+            <a:r>
+              <a:rPr lang="pt-BR" dirty="0"/>
+              <a:t>Plataforma de Telemedicina</a:t>
+            </a:r>
+          </a:p>
+          <a:p>
+            <a:pPr rtl="0"/>
+            <a:r>
+              <a:rPr lang="pt-BR" dirty="0"/>
+              <a:t>Lucas Schwertz</a:t>
+            </a:r>
+          </a:p>
+          <a:p>
+            <a:pPr rtl="0"/>
+            <a:r>
+              <a:rPr lang="pt-BR" dirty="0"/>
+              <a:t>Práticas Extensionistas III</a:t>
+            </a:r>
+          </a:p>
+          <a:p>
+            <a:pPr rtl="0"/>
+            <a:r>
+              <a:rPr lang="pt-BR" dirty="0"/>
+              <a:t>UNOESC – 2026</a:t>
+            </a:r>
+          </a:p>
+          <a:p>
+            <a:pPr rtl="0"/>
+            <a:r>
+              <a:rPr lang="pt-BR" dirty="0"/>
+              <a:t>Dúvidas?</a:t>
+            </a:r>
+          </a:p>
+        </p:txBody>
+      </p:sp>
+      <p:pic>
+        <p:nvPicPr>
+          <p:cNvPr id="25" name="Espaço Reservado para Imagem 24" descr="Imagem ampliada de uma rede">
+            <a:extLst>
+              <a:ext uri="{FF2B5EF4-FFF2-40B4-BE49-F238E27FC236}">
+                <a16:creationId xmlns:a16="http://schemas.microsoft.com/office/drawing/2014/main" id="{41A1C574-72C6-642F-E4D2-FF0C993AEF78}"/>
+              </a:ext>
+            </a:extLst>
+          </p:cNvPr>
+          <p:cNvPicPr>
+            <a:picLocks noGrp="1" noChangeAspect="1"/>
+          </p:cNvPicPr>
+          <p:nvPr>
+            <p:ph type="pic" sz="quarter" idx="13"/>
+          </p:nvPr>
+        </p:nvPicPr>
+        <p:blipFill>
+          <a:blip r:embed="rId3">
+            <a:extLst>
+              <a:ext uri="{28A0092B-C50C-407E-A947-70E740481C1C}">
+                <a14:useLocalDpi xmlns:a14="http://schemas.microsoft.com/office/drawing/2010/main" val="0"/>
+              </a:ext>
+            </a:extLst>
+          </a:blip>
+          <a:srcRect t="1" b="1"/>
+          <a:stretch/>
+        </p:blipFill>
+        <p:spPr>
+          <a:xfrm>
+            <a:off x="5926138" y="549275"/>
+            <a:ext cx="5654675" cy="5788025"/>
+          </a:xfrm>
+        </p:spPr>
+      </p:pic>
+    </p:spTree>
+    <p:extLst>
+      <p:ext uri="{BB962C8B-B14F-4D97-AF65-F5344CB8AC3E}">
+        <p14:creationId xmlns:p14="http://schemas.microsoft.com/office/powerpoint/2010/main" val="2547630249"/>
+      </p:ext>
+    </p:extLst>
+  </p:cSld>
+  <p:clrMapOvr>
+    <a:masterClrMapping/>
+  </p:clrMapOvr>
+</p:sld>
+</file>
+
 <file path=ppt/slides/slide2.xml><?xml version="1.0" encoding="utf-8"?>
 <p:sld xmlns:a="http://schemas.openxmlformats.org/drawingml/2006/main" xmlns:r="http://schemas.openxmlformats.org/officeDocument/2006/relationships" xmlns:p="http://schemas.openxmlformats.org/presentationml/2006/main">
   <p:cSld>
@@ -13036,6 +13305,193 @@
           <p:cNvPr id="2" name="Título 1">
             <a:extLst>
               <a:ext uri="{FF2B5EF4-FFF2-40B4-BE49-F238E27FC236}">
+                <a16:creationId xmlns:a16="http://schemas.microsoft.com/office/drawing/2014/main" id="{954ABE40-AA00-F366-A36A-B3F1AADBF025}"/>
+              </a:ext>
+            </a:extLst>
+          </p:cNvPr>
+          <p:cNvSpPr>
+            <a:spLocks noGrp="1"/>
+          </p:cNvSpPr>
+          <p:nvPr>
+            <p:ph type="ctrTitle"/>
+          </p:nvPr>
+        </p:nvSpPr>
+        <p:spPr>
+          <a:xfrm>
+            <a:off x="550863" y="196900"/>
+            <a:ext cx="4159160" cy="1945665"/>
+          </a:xfrm>
+          <a:noFill/>
+        </p:spPr>
+        <p:txBody>
+          <a:bodyPr rtlCol="0">
+            <a:noAutofit/>
+          </a:bodyPr>
+          <a:lstStyle>
+            <a:defPPr>
+              <a:defRPr lang="pt-BR"/>
+            </a:defPPr>
+          </a:lstStyle>
+          <a:p>
+            <a:pPr rtl="0"/>
+            <a:r>
+              <a:rPr lang="pt-BR" dirty="0"/>
+              <a:t>Diagrama de Caso de Uso</a:t>
+            </a:r>
+          </a:p>
+        </p:txBody>
+      </p:sp>
+      <p:sp>
+        <p:nvSpPr>
+          <p:cNvPr id="3" name="Subtítulo 2">
+            <a:extLst>
+              <a:ext uri="{FF2B5EF4-FFF2-40B4-BE49-F238E27FC236}">
+                <a16:creationId xmlns:a16="http://schemas.microsoft.com/office/drawing/2014/main" id="{72446868-83F0-CEEF-5E60-6D55C93B523F}"/>
+              </a:ext>
+            </a:extLst>
+          </p:cNvPr>
+          <p:cNvSpPr>
+            <a:spLocks noGrp="1"/>
+          </p:cNvSpPr>
+          <p:nvPr>
+            <p:ph type="subTitle" idx="1"/>
+          </p:nvPr>
+        </p:nvSpPr>
+        <p:spPr>
+          <a:xfrm>
+            <a:off x="550863" y="2788024"/>
+            <a:ext cx="4827961" cy="3092823"/>
+          </a:xfrm>
+          <a:noFill/>
+        </p:spPr>
+        <p:txBody>
+          <a:bodyPr rtlCol="0"/>
+          <a:lstStyle>
+            <a:defPPr>
+              <a:defRPr lang="pt-BR"/>
+            </a:defPPr>
+          </a:lstStyle>
+          <a:p>
+            <a:pPr rtl="0"/>
+            <a:r>
+              <a:rPr lang="pt-BR" sz="1400" dirty="0"/>
+              <a:t>O diagrama de caso de uso apresenta as principais interações entre os usuários e a plataforma de telemedicina.</a:t>
+            </a:r>
+          </a:p>
+          <a:p>
+            <a:pPr rtl="0"/>
+            <a:r>
+              <a:rPr lang="pt-BR" sz="1400" dirty="0"/>
+              <a:t>Principais funcionalidades:</a:t>
+            </a:r>
+          </a:p>
+          <a:p>
+            <a:pPr rtl="0"/>
+            <a:r>
+              <a:rPr lang="pt-BR" sz="1400" dirty="0"/>
+              <a:t>• Realizar login</a:t>
+            </a:r>
+          </a:p>
+          <a:p>
+            <a:pPr rtl="0"/>
+            <a:r>
+              <a:rPr lang="pt-BR" sz="1400" dirty="0"/>
+              <a:t>• Buscar médico</a:t>
+            </a:r>
+          </a:p>
+          <a:p>
+            <a:pPr rtl="0"/>
+            <a:r>
+              <a:rPr lang="pt-BR" sz="1400" dirty="0"/>
+              <a:t>• Consultar horários</a:t>
+            </a:r>
+          </a:p>
+          <a:p>
+            <a:pPr rtl="0"/>
+            <a:r>
+              <a:rPr lang="pt-BR" sz="1400" dirty="0"/>
+              <a:t>• Agendar consulta</a:t>
+            </a:r>
+          </a:p>
+          <a:p>
+            <a:pPr rtl="0"/>
+            <a:r>
+              <a:rPr lang="pt-BR" sz="1400" dirty="0"/>
+              <a:t>• Confirmar consulta</a:t>
+            </a:r>
+          </a:p>
+          <a:p>
+            <a:pPr rtl="0"/>
+            <a:r>
+              <a:rPr lang="pt-BR" sz="1400" dirty="0"/>
+              <a:t>• Realizar atendimento</a:t>
+            </a:r>
+          </a:p>
+        </p:txBody>
+      </p:sp>
+      <p:pic>
+        <p:nvPicPr>
+          <p:cNvPr id="5" name="Imagem 4">
+            <a:extLst>
+              <a:ext uri="{FF2B5EF4-FFF2-40B4-BE49-F238E27FC236}">
+                <a16:creationId xmlns:a16="http://schemas.microsoft.com/office/drawing/2014/main" id="{2CBBF5FF-6C6B-41CA-A3BB-AA4C61DE1948}"/>
+              </a:ext>
+            </a:extLst>
+          </p:cNvPr>
+          <p:cNvPicPr/>
+          <p:nvPr/>
+        </p:nvPicPr>
+        <p:blipFill>
+          <a:blip r:embed="rId3"/>
+          <a:stretch>
+            <a:fillRect/>
+          </a:stretch>
+        </p:blipFill>
+        <p:spPr>
+          <a:xfrm>
+            <a:off x="5253318" y="1524000"/>
+            <a:ext cx="6660775" cy="4195481"/>
+          </a:xfrm>
+          <a:prstGeom prst="rect">
+            <a:avLst/>
+          </a:prstGeom>
+        </p:spPr>
+      </p:pic>
+    </p:spTree>
+    <p:extLst>
+      <p:ext uri="{BB962C8B-B14F-4D97-AF65-F5344CB8AC3E}">
+        <p14:creationId xmlns:p14="http://schemas.microsoft.com/office/powerpoint/2010/main" val="3812248034"/>
+      </p:ext>
+    </p:extLst>
+  </p:cSld>
+  <p:clrMapOvr>
+    <a:masterClrMapping/>
+  </p:clrMapOvr>
+</p:sld>
+</file>
+
+<file path=ppt/slides/slide6.xml><?xml version="1.0" encoding="utf-8"?>
+<p:sld xmlns:a="http://schemas.openxmlformats.org/drawingml/2006/main" xmlns:r="http://schemas.openxmlformats.org/officeDocument/2006/relationships" xmlns:p="http://schemas.openxmlformats.org/presentationml/2006/main">
+  <p:cSld>
+    <p:spTree>
+      <p:nvGrpSpPr>
+        <p:cNvPr id="1" name=""/>
+        <p:cNvGrpSpPr/>
+        <p:nvPr/>
+      </p:nvGrpSpPr>
+      <p:grpSpPr>
+        <a:xfrm>
+          <a:off x="0" y="0"/>
+          <a:ext cx="0" cy="0"/>
+          <a:chOff x="0" y="0"/>
+          <a:chExt cx="0" cy="0"/>
+        </a:xfrm>
+      </p:grpSpPr>
+      <p:sp>
+        <p:nvSpPr>
+          <p:cNvPr id="2" name="Título 1">
+            <a:extLst>
+              <a:ext uri="{FF2B5EF4-FFF2-40B4-BE49-F238E27FC236}">
                 <a16:creationId xmlns:a16="http://schemas.microsoft.com/office/drawing/2014/main" id="{1C72343A-9CB0-F2AD-EF62-5DEE3E97F956}"/>
               </a:ext>
             </a:extLst>
@@ -13235,7 +13691,7 @@
 </p:sld>
 </file>
 
-<file path=ppt/slides/slide6.xml><?xml version="1.0" encoding="utf-8"?>
+<file path=ppt/slides/slide7.xml><?xml version="1.0" encoding="utf-8"?>
 <p:sld xmlns:a="http://schemas.openxmlformats.org/drawingml/2006/main" xmlns:r="http://schemas.openxmlformats.org/officeDocument/2006/relationships" xmlns:p="http://schemas.openxmlformats.org/presentationml/2006/main">
   <p:cSld>
     <p:spTree>
@@ -13385,7 +13841,7 @@
 </p:sld>
 </file>
 
-<file path=ppt/slides/slide7.xml><?xml version="1.0" encoding="utf-8"?>
+<file path=ppt/slides/slide8.xml><?xml version="1.0" encoding="utf-8"?>
 <p:sld xmlns:a="http://schemas.openxmlformats.org/drawingml/2006/main" xmlns:r="http://schemas.openxmlformats.org/officeDocument/2006/relationships" xmlns:p="http://schemas.openxmlformats.org/presentationml/2006/main">
   <p:cSld>
     <p:spTree>
@@ -13842,7 +14298,7 @@
 </p:sld>
 </file>
 
-<file path=ppt/slides/slide8.xml><?xml version="1.0" encoding="utf-8"?>
+<file path=ppt/slides/slide9.xml><?xml version="1.0" encoding="utf-8"?>
 <p:sld xmlns:a="http://schemas.openxmlformats.org/drawingml/2006/main" xmlns:r="http://schemas.openxmlformats.org/officeDocument/2006/relationships" xmlns:p="http://schemas.openxmlformats.org/presentationml/2006/main">
   <p:cSld>
     <p:spTree>
@@ -14618,180 +15074,6 @@
     <p:extLst>
       <p:ext uri="{BB962C8B-B14F-4D97-AF65-F5344CB8AC3E}">
         <p14:creationId xmlns:p14="http://schemas.microsoft.com/office/powerpoint/2010/main" val="414523832"/>
-      </p:ext>
-    </p:extLst>
-  </p:cSld>
-  <p:clrMapOvr>
-    <a:masterClrMapping/>
-  </p:clrMapOvr>
-</p:sld>
-</file>
-
-<file path=ppt/slides/slide9.xml><?xml version="1.0" encoding="utf-8"?>
-<p:sld xmlns:a="http://schemas.openxmlformats.org/drawingml/2006/main" xmlns:r="http://schemas.openxmlformats.org/officeDocument/2006/relationships" xmlns:p="http://schemas.openxmlformats.org/presentationml/2006/main">
-  <p:cSld>
-    <p:spTree>
-      <p:nvGrpSpPr>
-        <p:cNvPr id="1" name=""/>
-        <p:cNvGrpSpPr/>
-        <p:nvPr/>
-      </p:nvGrpSpPr>
-      <p:grpSpPr>
-        <a:xfrm>
-          <a:off x="0" y="0"/>
-          <a:ext cx="0" cy="0"/>
-          <a:chOff x="0" y="0"/>
-          <a:chExt cx="0" cy="0"/>
-        </a:xfrm>
-      </p:grpSpPr>
-      <p:sp>
-        <p:nvSpPr>
-          <p:cNvPr id="2" name="Título 1">
-            <a:extLst>
-              <a:ext uri="{FF2B5EF4-FFF2-40B4-BE49-F238E27FC236}">
-                <a16:creationId xmlns:a16="http://schemas.microsoft.com/office/drawing/2014/main" id="{28BAC361-0D7A-DC05-86B5-6DD77D322F5B}"/>
-              </a:ext>
-            </a:extLst>
-          </p:cNvPr>
-          <p:cNvSpPr>
-            <a:spLocks noGrp="1"/>
-          </p:cNvSpPr>
-          <p:nvPr>
-            <p:ph type="title"/>
-          </p:nvPr>
-        </p:nvSpPr>
-        <p:spPr>
-          <a:xfrm>
-            <a:off x="549536" y="549275"/>
-            <a:ext cx="5179330" cy="1082302"/>
-          </a:xfrm>
-          <a:noFill/>
-        </p:spPr>
-        <p:txBody>
-          <a:bodyPr rtlCol="0" anchor="b">
-            <a:normAutofit/>
-          </a:bodyPr>
-          <a:lstStyle>
-            <a:defPPr>
-              <a:defRPr lang="pt-BR"/>
-            </a:defPPr>
-          </a:lstStyle>
-          <a:p>
-            <a:pPr rtl="0"/>
-            <a:r>
-              <a:rPr lang="pt-BR" dirty="0"/>
-              <a:t>Obrigado!</a:t>
-            </a:r>
-          </a:p>
-        </p:txBody>
-      </p:sp>
-      <p:sp>
-        <p:nvSpPr>
-          <p:cNvPr id="3" name="Espaço Reservado para Conteúdo 2">
-            <a:extLst>
-              <a:ext uri="{FF2B5EF4-FFF2-40B4-BE49-F238E27FC236}">
-                <a16:creationId xmlns:a16="http://schemas.microsoft.com/office/drawing/2014/main" id="{1BE98EFF-197D-3136-70B9-7BBD30A48931}"/>
-              </a:ext>
-            </a:extLst>
-          </p:cNvPr>
-          <p:cNvSpPr>
-            <a:spLocks noGrp="1"/>
-          </p:cNvSpPr>
-          <p:nvPr>
-            <p:ph idx="1"/>
-          </p:nvPr>
-        </p:nvSpPr>
-        <p:spPr>
-          <a:xfrm>
-            <a:off x="549536" y="2090207"/>
-            <a:ext cx="5179330" cy="2706160"/>
-          </a:xfrm>
-          <a:noFill/>
-        </p:spPr>
-        <p:txBody>
-          <a:bodyPr rtlCol="0">
-            <a:normAutofit/>
-          </a:bodyPr>
-          <a:lstStyle>
-            <a:defPPr>
-              <a:defRPr lang="pt-BR"/>
-            </a:defPPr>
-          </a:lstStyle>
-          <a:p>
-            <a:pPr rtl="0"/>
-            <a:r>
-              <a:rPr lang="pt-BR" dirty="0"/>
-              <a:t>Plataforma de Telemedicina</a:t>
-            </a:r>
-          </a:p>
-          <a:p>
-            <a:pPr rtl="0"/>
-            <a:r>
-              <a:rPr lang="pt-BR" dirty="0"/>
-              <a:t>Lucas Schwertz</a:t>
-            </a:r>
-          </a:p>
-          <a:p>
-            <a:pPr rtl="0"/>
-            <a:r>
-              <a:rPr lang="pt-BR" dirty="0"/>
-              <a:t>Práticas Extensionistas III</a:t>
-            </a:r>
-          </a:p>
-          <a:p>
-            <a:pPr rtl="0"/>
-            <a:r>
-              <a:rPr lang="pt-BR" dirty="0"/>
-              <a:t>UNOESC – 2026</a:t>
-            </a:r>
-          </a:p>
-          <a:p>
-            <a:pPr rtl="0"/>
-            <a:r>
-              <a:rPr lang="pt-BR" dirty="0"/>
-              <a:t>Dúvidas?</a:t>
-            </a:r>
-          </a:p>
-        </p:txBody>
-      </p:sp>
-      <p:pic>
-        <p:nvPicPr>
-          <p:cNvPr id="25" name="Espaço Reservado para Imagem 24" descr="Imagem ampliada de uma rede">
-            <a:extLst>
-              <a:ext uri="{FF2B5EF4-FFF2-40B4-BE49-F238E27FC236}">
-                <a16:creationId xmlns:a16="http://schemas.microsoft.com/office/drawing/2014/main" id="{41A1C574-72C6-642F-E4D2-FF0C993AEF78}"/>
-              </a:ext>
-            </a:extLst>
-          </p:cNvPr>
-          <p:cNvPicPr>
-            <a:picLocks noGrp="1" noChangeAspect="1"/>
-          </p:cNvPicPr>
-          <p:nvPr>
-            <p:ph type="pic" sz="quarter" idx="13"/>
-          </p:nvPr>
-        </p:nvPicPr>
-        <p:blipFill>
-          <a:blip r:embed="rId3">
-            <a:extLst>
-              <a:ext uri="{28A0092B-C50C-407E-A947-70E740481C1C}">
-                <a14:useLocalDpi xmlns:a14="http://schemas.microsoft.com/office/drawing/2010/main" val="0"/>
-              </a:ext>
-            </a:extLst>
-          </a:blip>
-          <a:srcRect t="1" b="1"/>
-          <a:stretch/>
-        </p:blipFill>
-        <p:spPr>
-          <a:xfrm>
-            <a:off x="5926138" y="549275"/>
-            <a:ext cx="5654675" cy="5788025"/>
-          </a:xfrm>
-        </p:spPr>
-      </p:pic>
-    </p:spTree>
-    <p:extLst>
-      <p:ext uri="{BB962C8B-B14F-4D97-AF65-F5344CB8AC3E}">
-        <p14:creationId xmlns:p14="http://schemas.microsoft.com/office/powerpoint/2010/main" val="2547630249"/>
       </p:ext>
     </p:extLst>
   </p:cSld>
@@ -15593,35 +15875,6 @@
 </file>
 
 <file path=customXml/item1.xml><?xml version="1.0" encoding="utf-8"?>
-<?mso-contentType ?>
-<FormTemplates xmlns="http://schemas.microsoft.com/sharepoint/v3/contenttype/forms">
-  <Display>DocumentLibraryForm</Display>
-  <Edit>DocumentLibraryForm</Edit>
-  <New>DocumentLibraryForm</New>
-</FormTemplates>
-</file>
-
-<file path=customXml/item2.xml><?xml version="1.0" encoding="utf-8"?>
-<p:properties xmlns:p="http://schemas.microsoft.com/office/2006/metadata/properties" xmlns:xsi="http://www.w3.org/2001/XMLSchema-instance" xmlns:pc="http://schemas.microsoft.com/office/infopath/2007/PartnerControls">
-  <documentManagement>
-    <_ip_UnifiedCompliancePolicyUIAction xmlns="http://schemas.microsoft.com/sharepoint/v3" xsi:nil="true"/>
-    <Image xmlns="71af3243-3dd4-4a8d-8c0d-dd76da1f02a5">
-      <Url xsi:nil="true"/>
-      <Description xsi:nil="true"/>
-    </Image>
-    <Status xmlns="71af3243-3dd4-4a8d-8c0d-dd76da1f02a5">Not started</Status>
-    <Background xmlns="71af3243-3dd4-4a8d-8c0d-dd76da1f02a5">false</Background>
-    <_ip_UnifiedCompliancePolicyProperties xmlns="http://schemas.microsoft.com/sharepoint/v3" xsi:nil="true"/>
-    <ImageTagsTaxHTField xmlns="71af3243-3dd4-4a8d-8c0d-dd76da1f02a5">
-      <Terms xmlns="http://schemas.microsoft.com/office/infopath/2007/PartnerControls"/>
-    </ImageTagsTaxHTField>
-    <TaxCatchAll xmlns="230e9df3-be65-4c73-a93b-d1236ebd677e" xsi:nil="true"/>
-    <MediaServiceKeyPoints xmlns="71af3243-3dd4-4a8d-8c0d-dd76da1f02a5" xsi:nil="true"/>
-  </documentManagement>
-</p:properties>
-</file>
-
-<file path=customXml/item3.xml><?xml version="1.0" encoding="utf-8"?>
 <ct:contentTypeSchema xmlns:ct="http://schemas.microsoft.com/office/2006/metadata/contentType" xmlns:ma="http://schemas.microsoft.com/office/2006/metadata/properties/metaAttributes" ct:_="" ma:_="" ma:contentTypeName="Document" ma:contentTypeID="0x01010079F111ED35F8CC479449609E8A0923A6" ma:contentTypeVersion="28" ma:contentTypeDescription="Create a new document." ma:contentTypeScope="" ma:versionID="60f5a4f2d2b0abadcf532d48ebf9cb71">
   <xsd:schema xmlns:xsd="http://www.w3.org/2001/XMLSchema" xmlns:xs="http://www.w3.org/2001/XMLSchema" xmlns:p="http://schemas.microsoft.com/office/2006/metadata/properties" xmlns:ns1="http://schemas.microsoft.com/sharepoint/v3" xmlns:ns2="71af3243-3dd4-4a8d-8c0d-dd76da1f02a5" xmlns:ns3="16c05727-aa75-4e4a-9b5f-8a80a1165891" xmlns:ns4="230e9df3-be65-4c73-a93b-d1236ebd677e" targetNamespace="http://schemas.microsoft.com/office/2006/metadata/properties" ma:root="true" ma:fieldsID="7dd78129e6a1811f84807ad11c651531" ns1:_="" ns2:_="" ns3:_="" ns4:_="">
     <xsd:import namespace="http://schemas.microsoft.com/sharepoint/v3"/>
@@ -15933,10 +16186,52 @@
 </ct:contentTypeSchema>
 </file>
 
+<file path=customXml/item2.xml><?xml version="1.0" encoding="utf-8"?>
+<p:properties xmlns:p="http://schemas.microsoft.com/office/2006/metadata/properties" xmlns:xsi="http://www.w3.org/2001/XMLSchema-instance" xmlns:pc="http://schemas.microsoft.com/office/infopath/2007/PartnerControls">
+  <documentManagement>
+    <_ip_UnifiedCompliancePolicyUIAction xmlns="http://schemas.microsoft.com/sharepoint/v3" xsi:nil="true"/>
+    <Image xmlns="71af3243-3dd4-4a8d-8c0d-dd76da1f02a5">
+      <Url xsi:nil="true"/>
+      <Description xsi:nil="true"/>
+    </Image>
+    <Status xmlns="71af3243-3dd4-4a8d-8c0d-dd76da1f02a5">Not started</Status>
+    <Background xmlns="71af3243-3dd4-4a8d-8c0d-dd76da1f02a5">false</Background>
+    <_ip_UnifiedCompliancePolicyProperties xmlns="http://schemas.microsoft.com/sharepoint/v3" xsi:nil="true"/>
+    <ImageTagsTaxHTField xmlns="71af3243-3dd4-4a8d-8c0d-dd76da1f02a5">
+      <Terms xmlns="http://schemas.microsoft.com/office/infopath/2007/PartnerControls"/>
+    </ImageTagsTaxHTField>
+    <TaxCatchAll xmlns="230e9df3-be65-4c73-a93b-d1236ebd677e" xsi:nil="true"/>
+    <MediaServiceKeyPoints xmlns="71af3243-3dd4-4a8d-8c0d-dd76da1f02a5" xsi:nil="true"/>
+  </documentManagement>
+</p:properties>
+</file>
+
+<file path=customXml/item3.xml><?xml version="1.0" encoding="utf-8"?>
+<?mso-contentType ?>
+<FormTemplates xmlns="http://schemas.microsoft.com/sharepoint/v3/contenttype/forms">
+  <Display>DocumentLibraryForm</Display>
+  <Edit>DocumentLibraryForm</Edit>
+  <New>DocumentLibraryForm</New>
+</FormTemplates>
+</file>
+
 <file path=customXml/itemProps1.xml><?xml version="1.0" encoding="utf-8"?>
-<ds:datastoreItem xmlns:ds="http://schemas.openxmlformats.org/officeDocument/2006/customXml" ds:itemID="{2F49CD38-5B57-4682-9FCE-B9174068D0AE}">
+<ds:datastoreItem xmlns:ds="http://schemas.openxmlformats.org/officeDocument/2006/customXml" ds:itemID="{797783A8-901D-4F73-81D7-AA6841BEB3D7}">
   <ds:schemaRefs>
-    <ds:schemaRef ds:uri="http://schemas.microsoft.com/sharepoint/v3/contenttype/forms"/>
+    <ds:schemaRef ds:uri="http://schemas.microsoft.com/office/2006/metadata/contentType"/>
+    <ds:schemaRef ds:uri="http://schemas.microsoft.com/office/2006/metadata/properties/metaAttributes"/>
+    <ds:schemaRef ds:uri="http://www.w3.org/2001/XMLSchema"/>
+    <ds:schemaRef ds:uri="http://schemas.microsoft.com/office/2006/metadata/properties"/>
+    <ds:schemaRef ds:uri="http://schemas.microsoft.com/sharepoint/v3"/>
+    <ds:schemaRef ds:uri="71af3243-3dd4-4a8d-8c0d-dd76da1f02a5"/>
+    <ds:schemaRef ds:uri="16c05727-aa75-4e4a-9b5f-8a80a1165891"/>
+    <ds:schemaRef ds:uri="230e9df3-be65-4c73-a93b-d1236ebd677e"/>
+    <ds:schemaRef ds:uri="http://schemas.microsoft.com/office/2006/documentManagement/types"/>
+    <ds:schemaRef ds:uri="http://schemas.microsoft.com/office/infopath/2007/PartnerControls"/>
+    <ds:schemaRef ds:uri="http://schemas.openxmlformats.org/package/2006/metadata/core-properties"/>
+    <ds:schemaRef ds:uri="http://purl.org/dc/elements/1.1/"/>
+    <ds:schemaRef ds:uri="http://purl.org/dc/terms/"/>
+    <ds:schemaRef ds:uri="http://schemas.microsoft.com/internal/obd"/>
   </ds:schemaRefs>
 </ds:datastoreItem>
 </file>
@@ -15961,22 +16256,9 @@
 </file>
 
 <file path=customXml/itemProps3.xml><?xml version="1.0" encoding="utf-8"?>
-<ds:datastoreItem xmlns:ds="http://schemas.openxmlformats.org/officeDocument/2006/customXml" ds:itemID="{797783A8-901D-4F73-81D7-AA6841BEB3D7}">
+<ds:datastoreItem xmlns:ds="http://schemas.openxmlformats.org/officeDocument/2006/customXml" ds:itemID="{2F49CD38-5B57-4682-9FCE-B9174068D0AE}">
   <ds:schemaRefs>
-    <ds:schemaRef ds:uri="http://schemas.microsoft.com/office/2006/metadata/contentType"/>
-    <ds:schemaRef ds:uri="http://schemas.microsoft.com/office/2006/metadata/properties/metaAttributes"/>
-    <ds:schemaRef ds:uri="http://www.w3.org/2001/XMLSchema"/>
-    <ds:schemaRef ds:uri="http://schemas.microsoft.com/office/2006/metadata/properties"/>
-    <ds:schemaRef ds:uri="http://schemas.microsoft.com/sharepoint/v3"/>
-    <ds:schemaRef ds:uri="71af3243-3dd4-4a8d-8c0d-dd76da1f02a5"/>
-    <ds:schemaRef ds:uri="16c05727-aa75-4e4a-9b5f-8a80a1165891"/>
-    <ds:schemaRef ds:uri="230e9df3-be65-4c73-a93b-d1236ebd677e"/>
-    <ds:schemaRef ds:uri="http://schemas.microsoft.com/office/2006/documentManagement/types"/>
-    <ds:schemaRef ds:uri="http://schemas.microsoft.com/office/infopath/2007/PartnerControls"/>
-    <ds:schemaRef ds:uri="http://schemas.openxmlformats.org/package/2006/metadata/core-properties"/>
-    <ds:schemaRef ds:uri="http://purl.org/dc/elements/1.1/"/>
-    <ds:schemaRef ds:uri="http://purl.org/dc/terms/"/>
-    <ds:schemaRef ds:uri="http://schemas.microsoft.com/internal/obd"/>
+    <ds:schemaRef ds:uri="http://schemas.microsoft.com/sharepoint/v3/contenttype/forms"/>
   </ds:schemaRefs>
 </ds:datastoreItem>
 </file>

</xml_diff>